<commit_message>
Update presentation file for GitHub Copilot CLI
</commit_message>
<xml_diff>
--- a/docs/Getting Started with GitHub Copilot CLI.pptx
+++ b/docs/Getting Started with GitHub Copilot CLI.pptx
@@ -6739,7 +6739,11 @@
             <a:pPr marL="0" indent="0">
               <a:buNone/>
             </a:pPr>
-            <a:endParaRPr lang="en-US" dirty="0"/>
+            <a:endParaRPr lang="en-US" dirty="0">
+              <a:solidFill>
+                <a:srgbClr val="935EA0"/>
+              </a:solidFill>
+            </a:endParaRPr>
           </a:p>
         </p:txBody>
       </p:sp>
@@ -6771,7 +6775,11 @@
             <a:pPr marL="0" indent="0">
               <a:buNone/>
             </a:pPr>
-            <a:endParaRPr lang="en-US" dirty="0"/>
+            <a:endParaRPr lang="en-US" dirty="0">
+              <a:solidFill>
+                <a:srgbClr val="935EA0"/>
+              </a:solidFill>
+            </a:endParaRPr>
           </a:p>
         </p:txBody>
       </p:sp>
@@ -6835,7 +6843,7 @@
             <a:r>
               <a:rPr lang="en-US" sz="1600" dirty="0">
                 <a:solidFill>
-                  <a:srgbClr val="6E40C9"/>
+                  <a:srgbClr val="935EA0"/>
                 </a:solidFill>
                 <a:latin typeface="Calibri Light" pitchFamily="34" charset="0"/>
                 <a:ea typeface="Calibri Light" pitchFamily="34" charset="-122"/>
@@ -6843,7 +6851,11 @@
               </a:rPr>
               <a:t>COMMAND HISTORY NAVIGATION</a:t>
             </a:r>
-            <a:endParaRPr lang="en-US" sz="1600" dirty="0"/>
+            <a:endParaRPr lang="en-US" sz="1600" dirty="0">
+              <a:solidFill>
+                <a:srgbClr val="935EA0"/>
+              </a:solidFill>
+            </a:endParaRPr>
           </a:p>
         </p:txBody>
       </p:sp>
@@ -8039,7 +8051,7 @@
             <a:r>
               <a:rPr lang="en-US" sz="1600" dirty="0">
                 <a:solidFill>
-                  <a:srgbClr val="6E40C9"/>
+                  <a:srgbClr val="935EA0"/>
                 </a:solidFill>
                 <a:latin typeface="Calibri Light" pitchFamily="34" charset="0"/>
                 <a:ea typeface="Calibri Light" pitchFamily="34" charset="-122"/>
@@ -8047,7 +8059,11 @@
               </a:rPr>
               <a:t>THE /HELP COMMAND</a:t>
             </a:r>
-            <a:endParaRPr lang="en-US" sz="1600" dirty="0"/>
+            <a:endParaRPr lang="en-US" sz="1600" dirty="0">
+              <a:solidFill>
+                <a:srgbClr val="935EA0"/>
+              </a:solidFill>
+            </a:endParaRPr>
           </a:p>
         </p:txBody>
       </p:sp>
@@ -9180,7 +9196,11 @@
             <a:pPr marL="0" indent="0">
               <a:buNone/>
             </a:pPr>
-            <a:endParaRPr lang="en-US" dirty="0"/>
+            <a:endParaRPr lang="en-US" dirty="0">
+              <a:solidFill>
+                <a:srgbClr val="935EA0"/>
+              </a:solidFill>
+            </a:endParaRPr>
           </a:p>
         </p:txBody>
       </p:sp>
@@ -22201,7 +22221,7 @@
         </p:nvSpPr>
         <p:spPr>
           <a:xfrm>
-            <a:off x="0" y="0"/>
+            <a:off x="0" y="168261"/>
             <a:ext cx="9144000" cy="5143500"/>
           </a:xfrm>
           <a:prstGeom prst="rect">
@@ -22873,40 +22893,6 @@
           </a:p>
         </p:txBody>
       </p:sp>
-      <p:sp>
-        <p:nvSpPr>
-          <p:cNvPr id="15" name="Text 13"/>
-          <p:cNvSpPr/>
-          <p:nvPr/>
-        </p:nvSpPr>
-        <p:spPr>
-          <a:xfrm>
-            <a:off x="2666405" y="1435745"/>
-            <a:ext cx="257770" cy="257770"/>
-          </a:xfrm>
-          <a:prstGeom prst="roundRect">
-            <a:avLst>
-              <a:gd name="adj" fmla="val 22171"/>
-            </a:avLst>
-          </a:prstGeom>
-          <a:solidFill>
-            <a:srgbClr val="6E40C9">
-              <a:alpha val="15000"/>
-            </a:srgbClr>
-          </a:solidFill>
-          <a:ln/>
-        </p:spPr>
-        <p:txBody>
-          <a:bodyPr wrap="none" rtlCol="0" anchor="t"/>
-          <a:lstStyle/>
-          <a:p>
-            <a:pPr marL="0" indent="0">
-              <a:buNone/>
-            </a:pPr>
-            <a:endParaRPr lang="en-US" dirty="0"/>
-          </a:p>
-        </p:txBody>
-      </p:sp>
       <p:pic>
         <p:nvPicPr>
           <p:cNvPr id="16" name="Image 0" descr="preencoded.png"/>
@@ -22929,8 +22915,8 @@
         </p:blipFill>
         <p:spPr>
           <a:xfrm>
-            <a:off x="2728921" y="1498262"/>
-            <a:ext cx="132588" cy="132588"/>
+            <a:off x="2588716" y="1498261"/>
+            <a:ext cx="272793" cy="272793"/>
           </a:xfrm>
           <a:prstGeom prst="rect">
             <a:avLst/>
@@ -23434,8 +23420,8 @@
         </p:blipFill>
         <p:spPr>
           <a:xfrm>
-            <a:off x="5491171" y="1498262"/>
-            <a:ext cx="132588" cy="132588"/>
+            <a:off x="5374934" y="1498261"/>
+            <a:ext cx="248825" cy="248825"/>
           </a:xfrm>
           <a:prstGeom prst="rect">
             <a:avLst/>
@@ -23883,40 +23869,6 @@
           </a:p>
         </p:txBody>
       </p:sp>
-      <p:sp>
-        <p:nvSpPr>
-          <p:cNvPr id="37" name="Text 31"/>
-          <p:cNvSpPr/>
-          <p:nvPr/>
-        </p:nvSpPr>
-        <p:spPr>
-          <a:xfrm>
-            <a:off x="8190905" y="1435745"/>
-            <a:ext cx="257770" cy="257770"/>
-          </a:xfrm>
-          <a:prstGeom prst="roundRect">
-            <a:avLst>
-              <a:gd name="adj" fmla="val 22171"/>
-            </a:avLst>
-          </a:prstGeom>
-          <a:solidFill>
-            <a:srgbClr val="6E40C9">
-              <a:alpha val="15000"/>
-            </a:srgbClr>
-          </a:solidFill>
-          <a:ln/>
-        </p:spPr>
-        <p:txBody>
-          <a:bodyPr wrap="none" rtlCol="0" anchor="t"/>
-          <a:lstStyle/>
-          <a:p>
-            <a:pPr marL="0" indent="0">
-              <a:buNone/>
-            </a:pPr>
-            <a:endParaRPr lang="en-US" dirty="0"/>
-          </a:p>
-        </p:txBody>
-      </p:sp>
       <p:pic>
         <p:nvPicPr>
           <p:cNvPr id="38" name="Image 4" descr="preencoded.png"/>
@@ -23939,8 +23891,8 @@
         </p:blipFill>
         <p:spPr>
           <a:xfrm>
-            <a:off x="8253421" y="1498262"/>
-            <a:ext cx="132588" cy="132588"/>
+            <a:off x="8104554" y="1498261"/>
+            <a:ext cx="281455" cy="281455"/>
           </a:xfrm>
           <a:prstGeom prst="rect">
             <a:avLst/>
@@ -24379,7 +24331,7 @@
         </p:nvSpPr>
         <p:spPr>
           <a:xfrm>
-            <a:off x="3487192" y="4718745"/>
+            <a:off x="2463641" y="4803993"/>
             <a:ext cx="2386578" cy="139005"/>
           </a:xfrm>
           <a:prstGeom prst="rect">
@@ -24399,7 +24351,7 @@
               <a:buNone/>
             </a:pPr>
             <a:r>
-              <a:rPr lang="en-US" sz="1000" dirty="0">
+              <a:rPr lang="en-US" dirty="0">
                 <a:solidFill>
                   <a:srgbClr val="8B949E"/>
                 </a:solidFill>
@@ -24409,7 +24361,7 @@
               </a:rPr>
               <a:t>All three methods install the same Copilot CLI binary.</a:t>
             </a:r>
-            <a:endParaRPr lang="en-US" sz="1000" dirty="0"/>
+            <a:endParaRPr lang="en-US" dirty="0"/>
           </a:p>
         </p:txBody>
       </p:sp>
@@ -27544,7 +27496,7 @@
               <a:buNone/>
             </a:pPr>
             <a:r>
-              <a:rPr lang="en-US" sz="620" kern="0" spc="31" dirty="0">
+              <a:rPr lang="en-US" sz="1600" kern="0" spc="31" dirty="0">
                 <a:solidFill>
                   <a:srgbClr val="A78BFA"/>
                 </a:solidFill>
@@ -27554,7 +27506,7 @@
               </a:rPr>
               <a:t>INSTALLATION METHODS</a:t>
             </a:r>
-            <a:endParaRPr lang="en-US" sz="620" dirty="0"/>
+            <a:endParaRPr lang="en-US" sz="1600" dirty="0"/>
           </a:p>
         </p:txBody>
       </p:sp>
@@ -28675,7 +28627,7 @@
               <a:buNone/>
             </a:pPr>
             <a:r>
-              <a:rPr lang="en-US" sz="960" b="1" dirty="0">
+              <a:rPr lang="en-US" sz="1600" b="1" dirty="0">
                 <a:solidFill>
                   <a:srgbClr val="E6EDF3"/>
                 </a:solidFill>
@@ -28685,7 +28637,7 @@
               </a:rPr>
               <a:t>Navigate to Your Project</a:t>
             </a:r>
-            <a:endParaRPr lang="en-US" sz="960" dirty="0"/>
+            <a:endParaRPr lang="en-US" sz="1600" dirty="0"/>
           </a:p>
         </p:txBody>
       </p:sp>
@@ -28711,13 +28663,10 @@
           <a:lstStyle/>
           <a:p>
             <a:pPr marL="0" indent="0" algn="l">
-              <a:lnSpc>
-                <a:spcPts val="1271"/>
-              </a:lnSpc>
-              <a:buNone/>
-            </a:pPr>
-            <a:r>
-              <a:rPr lang="en-US" sz="820" dirty="0">
+              <a:buNone/>
+            </a:pPr>
+            <a:r>
+              <a:rPr lang="en-US" sz="1400" dirty="0">
                 <a:solidFill>
                   <a:srgbClr val="8B949E"/>
                 </a:solidFill>
@@ -28728,7 +28677,7 @@
               <a:t>Open a terminal and </a:t>
             </a:r>
             <a:r>
-              <a:rPr lang="en-US" sz="730" dirty="0">
+              <a:rPr lang="en-US" sz="1400" dirty="0">
                 <a:solidFill>
                   <a:srgbClr val="A78BFA"/>
                 </a:solidFill>
@@ -28739,7 +28688,7 @@
               <a:t>cd</a:t>
             </a:r>
             <a:r>
-              <a:rPr lang="en-US" sz="820" dirty="0">
+              <a:rPr lang="en-US" sz="1400" dirty="0">
                 <a:solidFill>
                   <a:srgbClr val="8B949E"/>
                 </a:solidFill>
@@ -28749,7 +28698,7 @@
               </a:rPr>
               <a:t> into the project directory you want Copilot to help with.</a:t>
             </a:r>
-            <a:endParaRPr lang="en-US" sz="820" dirty="0"/>
+            <a:endParaRPr lang="en-US" sz="1400" dirty="0"/>
           </a:p>
         </p:txBody>
       </p:sp>
@@ -28761,8 +28710,8 @@
         </p:nvSpPr>
         <p:spPr>
           <a:xfrm>
-            <a:off x="610195" y="4133552"/>
-            <a:ext cx="997148" cy="221337"/>
+            <a:off x="610194" y="4133552"/>
+            <a:ext cx="1242051" cy="221337"/>
           </a:xfrm>
           <a:prstGeom prst="roundRect">
             <a:avLst>
@@ -28790,7 +28739,7 @@
               <a:buNone/>
             </a:pPr>
             <a:r>
-              <a:rPr lang="en-US" sz="730" dirty="0">
+              <a:rPr lang="en-US" sz="1200" dirty="0">
                 <a:solidFill>
                   <a:srgbClr val="A78BFA"/>
                 </a:solidFill>
@@ -28800,7 +28749,7 @@
               </a:rPr>
               <a:t>cd ~/my-project</a:t>
             </a:r>
-            <a:endParaRPr lang="en-US" sz="730" dirty="0"/>
+            <a:endParaRPr lang="en-US" sz="1200" dirty="0"/>
           </a:p>
         </p:txBody>
       </p:sp>
@@ -28971,7 +28920,7 @@
               <a:buNone/>
             </a:pPr>
             <a:r>
-              <a:rPr lang="en-US" sz="960" b="1" dirty="0">
+              <a:rPr lang="en-US" sz="1600" b="1" dirty="0">
                 <a:solidFill>
                   <a:srgbClr val="E6EDF3"/>
                 </a:solidFill>
@@ -28981,7 +28930,7 @@
               </a:rPr>
               <a:t>Launch the CLI</a:t>
             </a:r>
-            <a:endParaRPr lang="en-US" sz="960" dirty="0"/>
+            <a:endParaRPr lang="en-US" sz="1600" dirty="0"/>
           </a:p>
         </p:txBody>
       </p:sp>
@@ -29007,13 +28956,10 @@
           <a:lstStyle/>
           <a:p>
             <a:pPr marL="0" indent="0" algn="l">
-              <a:lnSpc>
-                <a:spcPts val="1271"/>
-              </a:lnSpc>
-              <a:buNone/>
-            </a:pPr>
-            <a:r>
-              <a:rPr lang="en-US" sz="820" dirty="0">
+              <a:buNone/>
+            </a:pPr>
+            <a:r>
+              <a:rPr lang="en-US" sz="1400" dirty="0">
                 <a:solidFill>
                   <a:srgbClr val="8B949E"/>
                 </a:solidFill>
@@ -29024,7 +28970,7 @@
               <a:t>Run the </a:t>
             </a:r>
             <a:r>
-              <a:rPr lang="en-US" sz="730" dirty="0">
+              <a:rPr lang="en-US" sz="1400" dirty="0">
                 <a:solidFill>
                   <a:srgbClr val="A78BFA"/>
                 </a:solidFill>
@@ -29035,7 +28981,7 @@
               <a:t>copilot</a:t>
             </a:r>
             <a:r>
-              <a:rPr lang="en-US" sz="820" dirty="0">
+              <a:rPr lang="en-US" sz="1400" dirty="0">
                 <a:solidFill>
                   <a:srgbClr val="8B949E"/>
                 </a:solidFill>
@@ -29045,7 +28991,7 @@
               </a:rPr>
               <a:t> command to start an interactive Copilot CLI session in your current directory.</a:t>
             </a:r>
-            <a:endParaRPr lang="en-US" sz="820" dirty="0"/>
+            <a:endParaRPr lang="en-US" sz="1400" dirty="0"/>
           </a:p>
         </p:txBody>
       </p:sp>
@@ -29057,8 +29003,8 @@
         </p:nvSpPr>
         <p:spPr>
           <a:xfrm>
-            <a:off x="2732038" y="4133552"/>
-            <a:ext cx="662732" cy="221337"/>
+            <a:off x="2732037" y="4133552"/>
+            <a:ext cx="1037425" cy="221337"/>
           </a:xfrm>
           <a:prstGeom prst="roundRect">
             <a:avLst>
@@ -29086,7 +29032,7 @@
               <a:buNone/>
             </a:pPr>
             <a:r>
-              <a:rPr lang="en-US" sz="730" dirty="0">
+              <a:rPr lang="en-US" sz="1200" dirty="0">
                 <a:solidFill>
                   <a:srgbClr val="A78BFA"/>
                 </a:solidFill>
@@ -29096,7 +29042,7 @@
               </a:rPr>
               <a:t>$ copilot</a:t>
             </a:r>
-            <a:endParaRPr lang="en-US" sz="730" dirty="0"/>
+            <a:endParaRPr lang="en-US" sz="1200" dirty="0"/>
           </a:p>
         </p:txBody>
       </p:sp>
@@ -29267,7 +29213,7 @@
               <a:buNone/>
             </a:pPr>
             <a:r>
-              <a:rPr lang="en-US" sz="960" b="1" dirty="0">
+              <a:rPr lang="en-US" sz="1600" b="1" dirty="0">
                 <a:solidFill>
                   <a:srgbClr val="E6EDF3"/>
                 </a:solidFill>
@@ -29277,7 +29223,7 @@
               </a:rPr>
               <a:t>Authenticate</a:t>
             </a:r>
-            <a:endParaRPr lang="en-US" sz="960" dirty="0"/>
+            <a:endParaRPr lang="en-US" sz="1600" dirty="0"/>
           </a:p>
         </p:txBody>
       </p:sp>
@@ -29303,13 +29249,10 @@
           <a:lstStyle/>
           <a:p>
             <a:pPr marL="0" indent="0" algn="l">
-              <a:lnSpc>
-                <a:spcPts val="1271"/>
-              </a:lnSpc>
-              <a:buNone/>
-            </a:pPr>
-            <a:r>
-              <a:rPr lang="en-US" sz="820" dirty="0">
+              <a:buNone/>
+            </a:pPr>
+            <a:r>
+              <a:rPr lang="en-US" sz="1400" dirty="0">
                 <a:solidFill>
                   <a:srgbClr val="8B949E"/>
                 </a:solidFill>
@@ -29320,7 +29263,7 @@
               <a:t>Enter </a:t>
             </a:r>
             <a:r>
-              <a:rPr lang="en-US" sz="730" dirty="0">
+              <a:rPr lang="en-US" sz="1400" dirty="0">
                 <a:solidFill>
                   <a:srgbClr val="A78BFA"/>
                 </a:solidFill>
@@ -29331,7 +29274,7 @@
               <a:t>/login</a:t>
             </a:r>
             <a:r>
-              <a:rPr lang="en-US" sz="820" dirty="0">
+              <a:rPr lang="en-US" sz="1400" dirty="0">
                 <a:solidFill>
                   <a:srgbClr val="8B949E"/>
                 </a:solidFill>
@@ -29342,7 +29285,7 @@
               <a:t> and follow the on-screen prompts to connect your GitHub account. </a:t>
             </a:r>
             <a:r>
-              <a:rPr lang="en-US" sz="730" dirty="0">
+              <a:rPr lang="en-US" sz="1400" dirty="0">
                 <a:solidFill>
                   <a:srgbClr val="A78BFA"/>
                 </a:solidFill>
@@ -29352,7 +29295,7 @@
               </a:rPr>
               <a:t>(one-time only)</a:t>
             </a:r>
-            <a:endParaRPr lang="en-US" sz="820" dirty="0"/>
+            <a:endParaRPr lang="en-US" sz="1400" dirty="0"/>
           </a:p>
         </p:txBody>
       </p:sp>
@@ -29365,7 +29308,7 @@
         <p:spPr>
           <a:xfrm>
             <a:off x="4853880" y="4133552"/>
-            <a:ext cx="495449" cy="221337"/>
+            <a:ext cx="843535" cy="221337"/>
           </a:xfrm>
           <a:prstGeom prst="roundRect">
             <a:avLst>
@@ -29393,7 +29336,7 @@
               <a:buNone/>
             </a:pPr>
             <a:r>
-              <a:rPr lang="en-US" sz="730" dirty="0">
+              <a:rPr lang="en-US" sz="1200" dirty="0">
                 <a:solidFill>
                   <a:srgbClr val="A78BFA"/>
                 </a:solidFill>
@@ -29403,7 +29346,7 @@
               </a:rPr>
               <a:t>/login</a:t>
             </a:r>
-            <a:endParaRPr lang="en-US" sz="730" dirty="0"/>
+            <a:endParaRPr lang="en-US" sz="1200" dirty="0"/>
           </a:p>
         </p:txBody>
       </p:sp>
@@ -29574,7 +29517,7 @@
               <a:buNone/>
             </a:pPr>
             <a:r>
-              <a:rPr lang="en-US" sz="960" b="1" dirty="0">
+              <a:rPr lang="en-US" sz="1600" b="1" dirty="0">
                 <a:solidFill>
                   <a:srgbClr val="E6EDF3"/>
                 </a:solidFill>
@@ -29584,7 +29527,7 @@
               </a:rPr>
               <a:t>Trust Your Directory</a:t>
             </a:r>
-            <a:endParaRPr lang="en-US" sz="960" dirty="0"/>
+            <a:endParaRPr lang="en-US" sz="1600" dirty="0"/>
           </a:p>
         </p:txBody>
       </p:sp>
@@ -29610,13 +29553,10 @@
           <a:lstStyle/>
           <a:p>
             <a:pPr marL="0" indent="0" algn="l">
-              <a:lnSpc>
-                <a:spcPts val="1271"/>
-              </a:lnSpc>
-              <a:buNone/>
-            </a:pPr>
-            <a:r>
-              <a:rPr lang="en-US" sz="820" dirty="0">
+              <a:buNone/>
+            </a:pPr>
+            <a:r>
+              <a:rPr lang="en-US" sz="1400" dirty="0">
                 <a:solidFill>
                   <a:srgbClr val="8B949E"/>
                 </a:solidFill>
@@ -29626,7 +29566,7 @@
               </a:rPr>
               <a:t>Confirm that files in the current directory are suitable for use with an AI tool when prompted by the CLI.</a:t>
             </a:r>
-            <a:endParaRPr lang="en-US" sz="820" dirty="0"/>
+            <a:endParaRPr lang="en-US" sz="1400" dirty="0"/>
           </a:p>
         </p:txBody>
       </p:sp>
@@ -29652,7 +29592,7 @@
         </p:blipFill>
         <p:spPr>
           <a:xfrm>
-            <a:off x="6947008" y="4198897"/>
+            <a:off x="6947008" y="4183267"/>
             <a:ext cx="132588" cy="132588"/>
           </a:xfrm>
           <a:prstGeom prst="rect">
@@ -29668,8 +29608,8 @@
         </p:nvSpPr>
         <p:spPr>
           <a:xfrm>
-            <a:off x="7094041" y="4195763"/>
-            <a:ext cx="764039" cy="139005"/>
+            <a:off x="7094040" y="4195763"/>
+            <a:ext cx="1439763" cy="132589"/>
           </a:xfrm>
           <a:prstGeom prst="rect">
             <a:avLst/>
@@ -29688,7 +29628,7 @@
               <a:buNone/>
             </a:pPr>
             <a:r>
-              <a:rPr lang="en-US" sz="730" dirty="0">
+              <a:rPr lang="en-US" sz="1200" dirty="0">
                 <a:solidFill>
                   <a:srgbClr val="A78BFA"/>
                 </a:solidFill>
@@ -29698,7 +29638,7 @@
               </a:rPr>
               <a:t>One-time prompt</a:t>
             </a:r>
-            <a:endParaRPr lang="en-US" sz="730" dirty="0"/>
+            <a:endParaRPr lang="en-US" sz="1200" dirty="0"/>
           </a:p>
         </p:txBody>
       </p:sp>
@@ -29764,8 +29704,8 @@
         </p:blipFill>
         <p:spPr>
           <a:xfrm>
-            <a:off x="586764" y="4713024"/>
-            <a:ext cx="132588" cy="132588"/>
+            <a:off x="392129" y="4605337"/>
+            <a:ext cx="330762" cy="330762"/>
           </a:xfrm>
           <a:prstGeom prst="rect">
             <a:avLst/>
@@ -29780,8 +29720,8 @@
         </p:nvSpPr>
         <p:spPr>
           <a:xfrm>
-            <a:off x="766911" y="4704159"/>
-            <a:ext cx="4035966" cy="150465"/>
+            <a:off x="766910" y="4704159"/>
+            <a:ext cx="7919889" cy="238720"/>
           </a:xfrm>
           <a:prstGeom prst="rect">
             <a:avLst/>
@@ -29800,7 +29740,7 @@
               <a:buNone/>
             </a:pPr>
             <a:r>
-              <a:rPr lang="en-US" sz="790" dirty="0">
+              <a:rPr lang="en-US" dirty="0">
                 <a:solidFill>
                   <a:srgbClr val="8B949E"/>
                 </a:solidFill>
@@ -29810,7 +29750,7 @@
               </a:rPr>
               <a:t>Safety guarantee: Copilot will never modify your files without your explicit approval.</a:t>
             </a:r>
-            <a:endParaRPr lang="en-US" sz="790" dirty="0"/>
+            <a:endParaRPr lang="en-US" dirty="0"/>
           </a:p>
         </p:txBody>
       </p:sp>
@@ -29897,7 +29837,7 @@
         </p:nvSpPr>
         <p:spPr>
           <a:xfrm>
-            <a:off x="0" y="0"/>
+            <a:off x="0" y="8792"/>
             <a:ext cx="9144000" cy="5143500"/>
           </a:xfrm>
           <a:prstGeom prst="rect">
@@ -31699,7 +31639,7 @@
         </p:nvSpPr>
         <p:spPr>
           <a:xfrm>
-            <a:off x="1203127" y="1383655"/>
+            <a:off x="1203127" y="1286943"/>
             <a:ext cx="406229" cy="133201"/>
           </a:xfrm>
           <a:prstGeom prst="roundRect">
@@ -31722,7 +31662,7 @@
               <a:buNone/>
             </a:pPr>
             <a:r>
-              <a:rPr lang="en-US" sz="900" dirty="0">
+              <a:rPr lang="en-US" sz="1600" dirty="0">
                 <a:solidFill>
                   <a:srgbClr val="9B72F5"/>
                 </a:solidFill>
@@ -31732,7 +31672,7 @@
               </a:rPr>
               <a:t>/login</a:t>
             </a:r>
-            <a:endParaRPr lang="en-US" sz="900" dirty="0"/>
+            <a:endParaRPr lang="en-US" sz="1600" dirty="0"/>
           </a:p>
         </p:txBody>
       </p:sp>
@@ -31744,7 +31684,7 @@
         </p:nvSpPr>
         <p:spPr>
           <a:xfrm>
-            <a:off x="1203127" y="1538436"/>
+            <a:off x="1203127" y="1573604"/>
             <a:ext cx="6427946" cy="145852"/>
           </a:xfrm>
           <a:prstGeom prst="rect">
@@ -31764,7 +31704,7 @@
               <a:buNone/>
             </a:pPr>
             <a:r>
-              <a:rPr lang="en-US" sz="1050" dirty="0">
+              <a:rPr lang="en-US" sz="1200" dirty="0">
                 <a:solidFill>
                   <a:srgbClr val="E6EDF3"/>
                 </a:solidFill>
@@ -31775,7 +31715,7 @@
               <a:t>Type </a:t>
             </a:r>
             <a:r>
-              <a:rPr lang="en-US" sz="1000" dirty="0">
+              <a:rPr lang="en-US" sz="1100" dirty="0">
                 <a:solidFill>
                   <a:srgbClr val="9B72F5"/>
                 </a:solidFill>
@@ -31786,7 +31726,7 @@
               <a:t>/login</a:t>
             </a:r>
             <a:r>
-              <a:rPr lang="en-US" sz="1050" dirty="0">
+              <a:rPr lang="en-US" sz="1200" dirty="0">
                 <a:solidFill>
                   <a:srgbClr val="E6EDF3"/>
                 </a:solidFill>
@@ -31796,7 +31736,7 @@
               </a:rPr>
               <a:t> at the Copilot CLI prompt to begin the authentication flow</a:t>
             </a:r>
-            <a:endParaRPr lang="en-US" sz="1050" dirty="0"/>
+            <a:endParaRPr lang="en-US" sz="1200" dirty="0"/>
           </a:p>
         </p:txBody>
       </p:sp>
@@ -31951,7 +31891,7 @@
         </p:nvSpPr>
         <p:spPr>
           <a:xfrm>
-            <a:off x="1203127" y="1959471"/>
+            <a:off x="1203127" y="1862759"/>
             <a:ext cx="599173" cy="133201"/>
           </a:xfrm>
           <a:prstGeom prst="roundRect">
@@ -31974,7 +31914,7 @@
               <a:buNone/>
             </a:pPr>
             <a:r>
-              <a:rPr lang="en-US" sz="900" dirty="0">
+              <a:rPr lang="en-US" sz="1600" dirty="0">
                 <a:solidFill>
                   <a:srgbClr val="9B72F5"/>
                 </a:solidFill>
@@ -31984,7 +31924,7 @@
               </a:rPr>
               <a:t>OAuth Flow</a:t>
             </a:r>
-            <a:endParaRPr lang="en-US" sz="900" dirty="0"/>
+            <a:endParaRPr lang="en-US" sz="1600" dirty="0"/>
           </a:p>
         </p:txBody>
       </p:sp>
@@ -31996,7 +31936,7 @@
         </p:nvSpPr>
         <p:spPr>
           <a:xfrm>
-            <a:off x="1203127" y="2114252"/>
+            <a:off x="1203127" y="2149420"/>
             <a:ext cx="6427946" cy="145852"/>
           </a:xfrm>
           <a:prstGeom prst="rect">
@@ -32016,7 +31956,7 @@
               <a:buNone/>
             </a:pPr>
             <a:r>
-              <a:rPr lang="en-US" sz="1050" dirty="0">
+              <a:rPr lang="en-US" sz="1200" dirty="0">
                 <a:solidFill>
                   <a:srgbClr val="E6EDF3"/>
                 </a:solidFill>
@@ -32026,7 +31966,7 @@
               </a:rPr>
               <a:t>Follow the on-screen prompts — your browser may open to complete OAuth with GitHub</a:t>
             </a:r>
-            <a:endParaRPr lang="en-US" sz="1050" dirty="0"/>
+            <a:endParaRPr lang="en-US" sz="1200" dirty="0"/>
           </a:p>
         </p:txBody>
       </p:sp>
@@ -32181,7 +32121,7 @@
         </p:nvSpPr>
         <p:spPr>
           <a:xfrm>
-            <a:off x="1203127" y="2535287"/>
+            <a:off x="1203127" y="2438575"/>
             <a:ext cx="792269" cy="133201"/>
           </a:xfrm>
           <a:prstGeom prst="roundRect">
@@ -32204,7 +32144,7 @@
               <a:buNone/>
             </a:pPr>
             <a:r>
-              <a:rPr lang="en-US" sz="900" dirty="0">
+              <a:rPr lang="en-US" sz="1600" dirty="0">
                 <a:solidFill>
                   <a:srgbClr val="9B72F5"/>
                 </a:solidFill>
@@ -32214,7 +32154,7 @@
               </a:rPr>
               <a:t>Saved Securely</a:t>
             </a:r>
-            <a:endParaRPr lang="en-US" sz="900" dirty="0"/>
+            <a:endParaRPr lang="en-US" sz="1600" dirty="0"/>
           </a:p>
         </p:txBody>
       </p:sp>
@@ -32226,7 +32166,7 @@
         </p:nvSpPr>
         <p:spPr>
           <a:xfrm>
-            <a:off x="1203127" y="2690068"/>
+            <a:off x="1203127" y="2725236"/>
             <a:ext cx="6427946" cy="145852"/>
           </a:xfrm>
           <a:prstGeom prst="rect">
@@ -32246,7 +32186,7 @@
               <a:buNone/>
             </a:pPr>
             <a:r>
-              <a:rPr lang="en-US" sz="1050" dirty="0">
+              <a:rPr lang="en-US" sz="1200" dirty="0">
                 <a:solidFill>
                   <a:srgbClr val="E6EDF3"/>
                 </a:solidFill>
@@ -32256,7 +32196,7 @@
               </a:rPr>
               <a:t>Once authenticated, credentials are stored securely — no need to log in again</a:t>
             </a:r>
-            <a:endParaRPr lang="en-US" sz="1050" dirty="0"/>
+            <a:endParaRPr lang="en-US" sz="1200" dirty="0"/>
           </a:p>
         </p:txBody>
       </p:sp>
@@ -32411,7 +32351,7 @@
         </p:nvSpPr>
         <p:spPr>
           <a:xfrm>
-            <a:off x="1203127" y="3111103"/>
+            <a:off x="1203127" y="3014391"/>
             <a:ext cx="550899" cy="133201"/>
           </a:xfrm>
           <a:prstGeom prst="roundRect">
@@ -32434,7 +32374,7 @@
               <a:buNone/>
             </a:pPr>
             <a:r>
-              <a:rPr lang="en-US" sz="900" dirty="0">
+              <a:rPr lang="en-US" sz="1600" dirty="0">
                 <a:solidFill>
                   <a:srgbClr val="9B72F5"/>
                 </a:solidFill>
@@ -32444,7 +32384,7 @@
               </a:rPr>
               <a:t>Org Users</a:t>
             </a:r>
-            <a:endParaRPr lang="en-US" sz="900" dirty="0"/>
+            <a:endParaRPr lang="en-US" sz="1600" dirty="0"/>
           </a:p>
         </p:txBody>
       </p:sp>
@@ -32456,7 +32396,7 @@
         </p:nvSpPr>
         <p:spPr>
           <a:xfrm>
-            <a:off x="1203127" y="3265884"/>
+            <a:off x="1203127" y="3301052"/>
             <a:ext cx="6427946" cy="145852"/>
           </a:xfrm>
           <a:prstGeom prst="rect">
@@ -32476,7 +32416,7 @@
               <a:buNone/>
             </a:pPr>
             <a:r>
-              <a:rPr lang="en-US" sz="1050" dirty="0">
+              <a:rPr lang="en-US" sz="1200" dirty="0">
                 <a:solidFill>
                   <a:srgbClr val="E6EDF3"/>
                 </a:solidFill>
@@ -32486,7 +32426,7 @@
               </a:rPr>
               <a:t>Organization users: ensure your org admin has enabled the Copilot CLI policy in settings</a:t>
             </a:r>
-            <a:endParaRPr lang="en-US" sz="1050" dirty="0"/>
+            <a:endParaRPr lang="en-US" sz="1200" dirty="0"/>
           </a:p>
         </p:txBody>
       </p:sp>
@@ -32641,7 +32581,7 @@
         </p:nvSpPr>
         <p:spPr>
           <a:xfrm>
-            <a:off x="1203127" y="3686919"/>
+            <a:off x="1203127" y="3590207"/>
             <a:ext cx="985212" cy="133201"/>
           </a:xfrm>
           <a:prstGeom prst="roundRect">
@@ -32664,7 +32604,7 @@
               <a:buNone/>
             </a:pPr>
             <a:r>
-              <a:rPr lang="en-US" sz="900" dirty="0">
+              <a:rPr lang="en-US" sz="1600" dirty="0">
                 <a:solidFill>
                   <a:srgbClr val="9B72F5"/>
                 </a:solidFill>
@@ -32674,7 +32614,7 @@
               </a:rPr>
               <a:t>Subscription Check</a:t>
             </a:r>
-            <a:endParaRPr lang="en-US" sz="900" dirty="0"/>
+            <a:endParaRPr lang="en-US" sz="1600" dirty="0"/>
           </a:p>
         </p:txBody>
       </p:sp>
@@ -32686,7 +32626,7 @@
         </p:nvSpPr>
         <p:spPr>
           <a:xfrm>
-            <a:off x="1203127" y="3841700"/>
+            <a:off x="1203127" y="3876868"/>
             <a:ext cx="6427946" cy="145852"/>
           </a:xfrm>
           <a:prstGeom prst="rect">
@@ -32706,7 +32646,7 @@
               <a:buNone/>
             </a:pPr>
             <a:r>
-              <a:rPr lang="en-US" sz="1050" dirty="0">
+              <a:rPr lang="en-US" sz="1200" dirty="0">
                 <a:solidFill>
                   <a:srgbClr val="E6EDF3"/>
                 </a:solidFill>
@@ -32716,7 +32656,7 @@
               </a:rPr>
               <a:t>Your GitHub Copilot subscription is verified at this point — all plans supported</a:t>
             </a:r>
-            <a:endParaRPr lang="en-US" sz="1050" dirty="0"/>
+            <a:endParaRPr lang="en-US" sz="1200" dirty="0"/>
           </a:p>
         </p:txBody>
       </p:sp>

</xml_diff>

<commit_message>
added squad source code
</commit_message>
<xml_diff>
--- a/docs/Getting Started with GitHub Copilot CLI.pptx
+++ b/docs/Getting Started with GitHub Copilot CLI.pptx
@@ -1898,7 +1898,7 @@
         </p:nvSpPr>
         <p:spPr>
           <a:xfrm>
-            <a:off x="0" y="238720"/>
+            <a:off x="0" y="246671"/>
             <a:ext cx="9144000" cy="5143500"/>
           </a:xfrm>
           <a:prstGeom prst="rect">
@@ -3057,8 +3057,8 @@
         </p:nvSpPr>
         <p:spPr>
           <a:xfrm>
-            <a:off x="3025586" y="2880122"/>
-            <a:ext cx="3092827" cy="236190"/>
+            <a:off x="2586244" y="2862858"/>
+            <a:ext cx="3971362" cy="236190"/>
           </a:xfrm>
           <a:prstGeom prst="rect">
             <a:avLst/>
@@ -20086,50 +20086,6 @@
       </p:grpSpPr>
       <p:sp>
         <p:nvSpPr>
-          <p:cNvPr id="2" name="Text 0"/>
-          <p:cNvSpPr/>
-          <p:nvPr/>
-        </p:nvSpPr>
-        <p:spPr>
-          <a:xfrm>
-            <a:off x="6286500" y="0"/>
-            <a:ext cx="2857500" cy="2428237"/>
-          </a:xfrm>
-          <a:prstGeom prst="rect">
-            <a:avLst/>
-          </a:prstGeom>
-          <a:gradFill rotWithShape="1">
-            <a:gsLst>
-              <a:gs pos="0">
-                <a:srgbClr val="6E40C9">
-                  <a:alpha val="12000"/>
-                </a:srgbClr>
-              </a:gs>
-              <a:gs pos="70000">
-                <a:srgbClr val="000000">
-                  <a:alpha val="0"/>
-                </a:srgbClr>
-              </a:gs>
-            </a:gsLst>
-            <a:path path="circle">
-              <a:fillToRect l="50000" t="50000" r="50000" b="50000"/>
-            </a:path>
-          </a:gradFill>
-          <a:ln/>
-        </p:spPr>
-        <p:txBody>
-          <a:bodyPr wrap="square" rtlCol="0" anchor="t"/>
-          <a:lstStyle/>
-          <a:p>
-            <a:pPr marL="0" indent="0">
-              <a:buNone/>
-            </a:pPr>
-            <a:endParaRPr lang="en-US" dirty="0"/>
-          </a:p>
-        </p:txBody>
-      </p:sp>
-      <p:sp>
-        <p:nvSpPr>
           <p:cNvPr id="3" name="Text 1"/>
           <p:cNvSpPr/>
           <p:nvPr/>
@@ -20948,7 +20904,18 @@
                 <a:ea typeface="Calibri Light" pitchFamily="34" charset="-122"/>
                 <a:cs typeface="Calibri Light" pitchFamily="34" charset="-120"/>
               </a:rPr>
-              <a:t>All Copilot Plans</a:t>
+              <a:t>All Copilot </a:t>
+            </a:r>
+            <a:r>
+              <a:rPr lang="en-US" sz="2800" kern="0" spc="-10" dirty="0">
+                <a:solidFill>
+                  <a:srgbClr val="9B6DFF"/>
+                </a:solidFill>
+                <a:latin typeface="Calibri Light" pitchFamily="34" charset="0"/>
+                <a:ea typeface="Calibri Light" pitchFamily="34" charset="-122"/>
+                <a:cs typeface="Calibri Light" pitchFamily="34" charset="-120"/>
+              </a:rPr>
+              <a:t>Plans</a:t>
             </a:r>
             <a:endParaRPr lang="en-US" sz="3200" dirty="0"/>
           </a:p>
@@ -21248,7 +21215,7 @@
               <a:buNone/>
             </a:pPr>
             <a:r>
-              <a:rPr lang="en-US" sz="3200" kern="0" spc="-10" dirty="0">
+              <a:rPr lang="en-US" sz="2800" kern="0" spc="-10" dirty="0">
                 <a:solidFill>
                   <a:srgbClr val="9B6DFF"/>
                 </a:solidFill>
@@ -21258,7 +21225,7 @@
               </a:rPr>
               <a:t>Organization Users</a:t>
             </a:r>
-            <a:endParaRPr lang="en-US" sz="3200" dirty="0"/>
+            <a:endParaRPr lang="en-US" sz="2800" dirty="0"/>
           </a:p>
         </p:txBody>
       </p:sp>
@@ -21543,7 +21510,7 @@
               <a:buNone/>
             </a:pPr>
             <a:r>
-              <a:rPr lang="en-US" sz="3200" kern="0" spc="-10" dirty="0">
+              <a:rPr lang="en-US" sz="2800" kern="0" spc="-10" dirty="0">
                 <a:solidFill>
                   <a:srgbClr val="9B6DFF"/>
                 </a:solidFill>
@@ -21839,7 +21806,7 @@
               <a:buNone/>
             </a:pPr>
             <a:r>
-              <a:rPr lang="en-US" sz="3200" kern="0" spc="-10" dirty="0">
+              <a:rPr lang="en-US" sz="2800" kern="0" spc="-10" dirty="0">
                 <a:solidFill>
                   <a:srgbClr val="9B6DFF"/>
                 </a:solidFill>
@@ -21849,7 +21816,7 @@
               </a:rPr>
               <a:t>GitHub Authentication</a:t>
             </a:r>
-            <a:endParaRPr lang="en-US" sz="3200" dirty="0"/>
+            <a:endParaRPr lang="en-US" sz="2800" dirty="0"/>
           </a:p>
         </p:txBody>
       </p:sp>
@@ -27832,7 +27799,7 @@
         </p:nvSpPr>
         <p:spPr>
           <a:xfrm>
-            <a:off x="0" y="0"/>
+            <a:off x="0" y="15902"/>
             <a:ext cx="9144000" cy="5143500"/>
           </a:xfrm>
           <a:prstGeom prst="rect">

</xml_diff>